<commit_message>
Finalize report presentation and responsibilities
</commit_message>
<xml_diff>
--- a/docs/presentation.pptx
+++ b/docs/presentation.pptx
@@ -3959,13 +3959,13 @@
               </a:lnSpc>
             </a:pPr>
             <a:r>
-              <a:rPr sz="1600" b="0" i="0">
+              <a:rPr sz="1050" b="0" i="0">
                 <a:solidFill>
                   <a:srgbClr val="111827"/>
                 </a:solidFill>
                 <a:latin typeface="Calibri"/>
               </a:rPr>
-              <a:t>[Student 1]    [Student 2]    [Student 3]    [Student 4]    [Student 5]</a:t>
+              <a:t>Selvinaz Sayın (220901755)  -  Ege Karaurgan (229910141)  -  Vedat Efe Gezer (229910158)  -  Mehmet Emin Akkaya (2309011036)  -  Bayram Selim Yılmaz (2309011053)</a:t>
             </a:r>
           </a:p>
         </p:txBody>
@@ -4717,7 +4717,7 @@
                 </a:solidFill>
                 <a:latin typeface="Calibri"/>
               </a:rPr>
-              <a:t>[ MRI sample with GT overlay  ·  figures/eda_slice_grid.png ]</a:t>
+              <a:t/>
             </a:r>
           </a:p>
         </p:txBody>
@@ -4844,6 +4844,41 @@
           </a:p>
         </p:txBody>
       </p:sp>
+      <p:pic>
+        <p:nvPicPr>
+          <p:cNvPr id="50" name="EDA slice grid"/>
+          <p:cNvPicPr>
+            <a:picLocks noChangeAspect="1"/>
+          </p:cNvPicPr>
+          <p:nvPr/>
+        </p:nvPicPr>
+        <p:blipFill>
+          <a:blip r:embed="rId2">
+            <a:extLst>
+              <a:ext uri="{28A0092B-C50C-407E-A947-70E740481C1C}">
+                <a14:useLocalDpi xmlns:a14="http://schemas.microsoft.com/office/drawing/2010/main" val="0"/>
+              </a:ext>
+            </a:extLst>
+          </a:blip>
+          <a:stretch>
+            <a:fillRect/>
+          </a:stretch>
+        </p:blipFill>
+        <p:spPr>
+          <a:xfrm>
+            <a:off x="6766560" y="1417320"/>
+            <a:ext cx="4937760" cy="4663440"/>
+          </a:xfrm>
+          <a:prstGeom prst="rect">
+            <a:avLst/>
+          </a:prstGeom>
+          <a:ln>
+            <a:solidFill>
+              <a:srgbClr val="E5E7EB"/>
+            </a:solidFill>
+          </a:ln>
+        </p:spPr>
+      </p:pic>
     </p:spTree>
   </p:cSld>
   <p:clrMapOvr>
@@ -6861,7 +6896,7 @@
                 </a:solidFill>
                 <a:latin typeface="Calibri"/>
               </a:rPr>
-              <a:t>[ Optional: figures/architecture.png replaces this row when ready ]</a:t>
+              <a:t>Full implementation: 3D encoder, AE pretraining, ConvLSTM, attention decoder, and VAE diagnosis head.</a:t>
             </a:r>
           </a:p>
         </p:txBody>

</xml_diff>